<commit_message>
Actualiza la presentacion final: link real de GitHub, funcionalidad de pago (extra) y la correccion del carrito con ID obsoleto en el cierre
</commit_message>
<xml_diff>
--- a/docs/CAPTURE-TUC-presentacion.pptx
+++ b/docs/CAPTURE-TUC-presentacion.pptx
@@ -47,9 +47,10 @@
     <p:sldId id="295" r:id="rId41"/>
     <p:sldId id="296" r:id="rId42"/>
     <p:sldId id="297" r:id="rId43"/>
+    <p:sldId id="298" r:id="rId44"/>
   </p:sldIdLst>
   <p:notesMasterIdLst>
-    <p:notesMasterId r:id="rId44"/>
+    <p:notesMasterId r:id="rId45"/>
   </p:notesMasterIdLst>
   <p:sldSz cx="12188952" cy="6858000"/>
   <p:notesSz cx="6858000" cy="12188952"/>
@@ -3735,6 +3736,94 @@
             <a:fld id="{F7021451-1387-4CA6-816F-3879F97B5CBC}" type="slidenum">
               <a:rPr lang="en-US"/>
               <a:t>42</a:t>
+            </a:fld>
+            <a:endParaRPr lang="en-US"/>
+          </a:p>
+        </p:txBody>
+      </p:sp>
+    </p:spTree>
+    <p:extLst>
+      <p:ext uri="{BB962C8B-B14F-4D97-AF65-F5344CB8AC3E}">
+        <p14:creationId xmlns:p14="http://schemas.microsoft.com/office/powerpoint/2010/main" val="1024086991"/>
+      </p:ext>
+    </p:extLst>
+  </p:cSld>
+  <p:clrMapOvr>
+    <a:masterClrMapping/>
+  </p:clrMapOvr>
+</p:notes>
+</file>
+
+<file path=ppt/notesSlides/notesSlide43.xml><?xml version="1.0" encoding="utf-8"?>
+<p:notes xmlns:a="http://schemas.openxmlformats.org/drawingml/2006/main" xmlns:r="http://schemas.openxmlformats.org/officeDocument/2006/relationships" xmlns:p="http://schemas.openxmlformats.org/presentationml/2006/main">
+  <p:cSld>
+    <p:spTree>
+      <p:nvGrpSpPr>
+        <p:cNvPr id="1" name=""/>
+        <p:cNvGrpSpPr/>
+        <p:nvPr/>
+      </p:nvGrpSpPr>
+      <p:grpSpPr>
+        <a:xfrm>
+          <a:off x="0" y="0"/>
+          <a:ext cx="0" cy="0"/>
+          <a:chOff x="0" y="0"/>
+          <a:chExt cx="0" cy="0"/>
+        </a:xfrm>
+      </p:grpSpPr>
+      <p:sp>
+        <p:nvSpPr>
+          <p:cNvPr id="2" name="Slide Image Placeholder 1"/>
+          <p:cNvSpPr>
+            <a:spLocks noGrp="1" noRot="1" noChangeAspect="1"/>
+          </p:cNvSpPr>
+          <p:nvPr>
+            <p:ph type="sldImg"/>
+          </p:nvPr>
+        </p:nvSpPr>
+        <p:spPr/>
+      </p:sp>
+      <p:sp>
+        <p:nvSpPr>
+          <p:cNvPr id="3" name="Notes Placeholder 2"/>
+          <p:cNvSpPr>
+            <a:spLocks noGrp="1"/>
+          </p:cNvSpPr>
+          <p:nvPr>
+            <p:ph type="body" idx="1"/>
+          </p:nvPr>
+        </p:nvSpPr>
+        <p:spPr/>
+        <p:txBody>
+          <a:bodyPr/>
+          <a:lstStyle/>
+          <a:p>
+            <a:r>
+              <a:rPr lang="en-US" dirty="0"/>
+              <a:t/>
+            </a:r>
+            <a:endParaRPr lang="en-US" dirty="0"/>
+          </a:p>
+        </p:txBody>
+      </p:sp>
+      <p:sp>
+        <p:nvSpPr>
+          <p:cNvPr id="4" name="Slide Number Placeholder 3"/>
+          <p:cNvSpPr>
+            <a:spLocks noGrp="1"/>
+          </p:cNvSpPr>
+          <p:nvPr>
+            <p:ph type="sldNum" sz="quarter" idx="10"/>
+          </p:nvPr>
+        </p:nvSpPr>
+        <p:spPr/>
+        <p:txBody>
+          <a:bodyPr/>
+          <a:lstStyle/>
+          <a:p>
+            <a:fld id="{F7021451-1387-4CA6-816F-3879F97B5CBC}" type="slidenum">
+              <a:rPr lang="en-US"/>
+              <a:t>43</a:t>
             </a:fld>
             <a:endParaRPr lang="en-US"/>
           </a:p>
@@ -18354,7 +18443,7 @@
         <p:spPr>
           <a:xfrm>
             <a:off x="548640" y="411480"/>
-            <a:ext cx="2267712" cy="329184"/>
+            <a:ext cx="3072384" cy="329184"/>
           </a:xfrm>
           <a:prstGeom prst="roundRect">
             <a:avLst>
@@ -18376,7 +18465,7 @@
         <p:spPr>
           <a:xfrm>
             <a:off x="548640" y="411480"/>
-            <a:ext cx="2267712" cy="329184"/>
+            <a:ext cx="3072384" cy="329184"/>
           </a:xfrm>
           <a:prstGeom prst="rect">
             <a:avLst/>
@@ -18400,7 +18489,7 @@
                 <a:ea typeface="Calibri" pitchFamily="34" charset="-122"/>
                 <a:cs typeface="Calibri" pitchFamily="34" charset="-120"/>
               </a:rPr>
-              <a:t>8 · Funcionamiento</a:t>
+              <a:t>8 · Funcionamiento — extra</a:t>
             </a:r>
             <a:endParaRPr lang="en-US" sz="1200" dirty="0"/>
           </a:p>
@@ -18439,7 +18528,7 @@
                 <a:ea typeface="Calibri" pitchFamily="34" charset="-122"/>
                 <a:cs typeface="Calibri" pitchFamily="34" charset="-120"/>
               </a:rPr>
-              <a:t>Panel de gestión de productos</a:t>
+              <a:t>Opción de pago (Transferencia / Efectivo)</a:t>
             </a:r>
             <a:endParaRPr lang="en-US" sz="2600" dirty="0"/>
           </a:p>
@@ -18544,7 +18633,7 @@
                 <a:ea typeface="Calibri" pitchFamily="34" charset="-122"/>
                 <a:cs typeface="Calibri" pitchFamily="34" charset="-120"/>
               </a:rPr>
-              <a:t>Captura de /admin completo: el formulario de creación, el listado de fotolibros cargados y un formulario de edición desplegado.</a:t>
+              <a:t>Captura del carrito con el panel de "Finalizar compra" desplegado, mostrando Transferencia seleccionada: Alias, CVU, Nombre y el Monto real de esa compra.</a:t>
             </a:r>
             <a:endParaRPr lang="en-US" sz="1500" dirty="0"/>
           </a:p>
@@ -18583,7 +18672,7 @@
                 <a:ea typeface="Calibri" pitchFamily="34" charset="-122"/>
                 <a:cs typeface="Calibri" pitchFamily="34" charset="-120"/>
               </a:rPr>
-              <a:t>Cómo sacarla: abrí http://localhost:8080/admin directamente por URL (no tiene link en el menú público a propósito) y capturá el formulario y el listado.</a:t>
+              <a:t>Cómo sacarla: en /carts/:cid con productos cargados, hacé clic en "Finalizar compra", elegí "Transferencia" y capturá el panel con los datos bancarios y el monto. (Función extra, no pedida por la consigna técnica — se agregó para el negocio real.)</a:t>
             </a:r>
             <a:endParaRPr lang="en-US" sz="1250" dirty="0"/>
           </a:p>
@@ -18669,7 +18758,7 @@
         <p:spPr>
           <a:xfrm>
             <a:off x="548640" y="411480"/>
-            <a:ext cx="3675888" cy="329184"/>
+            <a:ext cx="2267712" cy="329184"/>
           </a:xfrm>
           <a:prstGeom prst="roundRect">
             <a:avLst>
@@ -18691,7 +18780,7 @@
         <p:spPr>
           <a:xfrm>
             <a:off x="548640" y="411480"/>
-            <a:ext cx="3675888" cy="329184"/>
+            <a:ext cx="2267712" cy="329184"/>
           </a:xfrm>
           <a:prstGeom prst="rect">
             <a:avLst/>
@@ -18715,7 +18804,7 @@
                 <a:ea typeface="Calibri" pitchFamily="34" charset="-122"/>
                 <a:cs typeface="Calibri" pitchFamily="34" charset="-120"/>
               </a:rPr>
-              <a:t>8 · Funcionamiento — obligatorio</a:t>
+              <a:t>8 · Funcionamiento</a:t>
             </a:r>
             <a:endParaRPr lang="en-US" sz="1200" dirty="0"/>
           </a:p>
@@ -18754,7 +18843,7 @@
                 <a:ea typeface="Calibri" pitchFamily="34" charset="-122"/>
                 <a:cs typeface="Calibri" pitchFamily="34" charset="-120"/>
               </a:rPr>
-              <a:t>GIF o video: recorrido completo del sistema</a:t>
+              <a:t>Panel de gestión de productos</a:t>
             </a:r>
             <a:endParaRPr lang="en-US" sz="2600" dirty="0"/>
           </a:p>
@@ -18859,7 +18948,7 @@
                 <a:ea typeface="Calibri" pitchFamily="34" charset="-122"/>
                 <a:cs typeface="Calibri" pitchFamily="34" charset="-120"/>
               </a:rPr>
-              <a:t>Grabación corta (GIF o video, 1-3 min) mostrando el flujo completo: home → catálogo → detalle con hojas extra → agregar al carrito → ver carrito → panel admin editando un producto → catálogo actualizándose solo por WebSockets.</a:t>
+              <a:t>Captura de /admin completo: el formulario de creación, el listado de fotolibros cargados y un formulario de edición desplegado.</a:t>
             </a:r>
             <a:endParaRPr lang="en-US" sz="1500" dirty="0"/>
           </a:p>
@@ -18898,7 +18987,7 @@
                 <a:ea typeface="Calibri" pitchFamily="34" charset="-122"/>
                 <a:cs typeface="Calibri" pitchFamily="34" charset="-120"/>
               </a:rPr>
-              <a:t>Cómo grabarlo: usá la grabadora de pantalla de Windows (Win+Alt+R) o una herramienta como ScreenToGif. Subilo a Drive/YouTube (no listado) y pegá el link o insertalo directamente en esta diapositiva.</a:t>
+              <a:t>Cómo sacarla: abrí http://localhost:8080/admin directamente por URL (no tiene link en el menú público a propósito) y capturá el formulario y el listado.</a:t>
             </a:r>
             <a:endParaRPr lang="en-US" sz="1250" dirty="0"/>
           </a:p>
@@ -18983,28 +19072,69 @@
         </p:nvSpPr>
         <p:spPr>
           <a:xfrm>
-            <a:off x="0" y="0"/>
-            <a:ext cx="12188952" cy="6858000"/>
+            <a:off x="548640" y="411480"/>
+            <a:ext cx="3675888" cy="329184"/>
+          </a:xfrm>
+          <a:prstGeom prst="roundRect">
+            <a:avLst>
+              <a:gd name="adj" fmla="val 22222"/>
+            </a:avLst>
+          </a:prstGeom>
+          <a:solidFill>
+            <a:srgbClr val="C6A369"/>
+          </a:solidFill>
+          <a:ln/>
+        </p:spPr>
+      </p:sp>
+      <p:sp>
+        <p:nvSpPr>
+          <p:cNvPr id="3" name="Text 1"/>
+          <p:cNvSpPr/>
+          <p:nvPr/>
+        </p:nvSpPr>
+        <p:spPr>
+          <a:xfrm>
+            <a:off x="548640" y="411480"/>
+            <a:ext cx="3675888" cy="329184"/>
           </a:xfrm>
           <a:prstGeom prst="rect">
             <a:avLst/>
           </a:prstGeom>
-          <a:solidFill>
-            <a:srgbClr val="6B4226"/>
-          </a:solidFill>
-          <a:ln/>
-        </p:spPr>
-      </p:sp>
-      <p:sp>
-        <p:nvSpPr>
-          <p:cNvPr id="3" name="Text 1"/>
-          <p:cNvSpPr/>
-          <p:nvPr/>
-        </p:nvSpPr>
-        <p:spPr>
-          <a:xfrm>
-            <a:off x="822960" y="2103120"/>
-            <a:ext cx="2743200" cy="1828800"/>
+          <a:noFill/>
+          <a:ln/>
+        </p:spPr>
+        <p:txBody>
+          <a:bodyPr wrap="square" rtlCol="0" anchor="ctr"/>
+          <a:lstStyle/>
+          <a:p>
+            <a:pPr algn="ctr" indent="0" marL="0">
+              <a:buNone/>
+            </a:pPr>
+            <a:r>
+              <a:rPr lang="en-US" sz="1200" b="1" dirty="0">
+                <a:solidFill>
+                  <a:srgbClr val="3B2418"/>
+                </a:solidFill>
+                <a:latin typeface="Calibri" pitchFamily="34" charset="0"/>
+                <a:ea typeface="Calibri" pitchFamily="34" charset="-122"/>
+                <a:cs typeface="Calibri" pitchFamily="34" charset="-120"/>
+              </a:rPr>
+              <a:t>8 · Funcionamiento — obligatorio</a:t>
+            </a:r>
+            <a:endParaRPr lang="en-US" sz="1200" dirty="0"/>
+          </a:p>
+        </p:txBody>
+      </p:sp>
+      <p:sp>
+        <p:nvSpPr>
+          <p:cNvPr id="4" name="Text 2"/>
+          <p:cNvSpPr/>
+          <p:nvPr/>
+        </p:nvSpPr>
+        <p:spPr>
+          <a:xfrm>
+            <a:off x="548640" y="822960"/>
+            <a:ext cx="11064240" cy="640080"/>
           </a:xfrm>
           <a:prstGeom prst="rect">
             <a:avLst/>
@@ -19020,30 +19150,57 @@
               <a:buNone/>
             </a:pPr>
             <a:r>
-              <a:rPr lang="en-US" sz="9000" b="1" dirty="0">
-                <a:solidFill>
-                  <a:srgbClr val="C6A369"/>
-                </a:solidFill>
-                <a:latin typeface="Calibri" pitchFamily="34" charset="0"/>
-                <a:ea typeface="Calibri" pitchFamily="34" charset="-122"/>
-                <a:cs typeface="Calibri" pitchFamily="34" charset="-120"/>
-              </a:rPr>
-              <a:t>9</a:t>
-            </a:r>
-            <a:endParaRPr lang="en-US" sz="9000" dirty="0"/>
-          </a:p>
-        </p:txBody>
-      </p:sp>
-      <p:sp>
-        <p:nvSpPr>
-          <p:cNvPr id="4" name="Text 2"/>
-          <p:cNvSpPr/>
-          <p:nvPr/>
-        </p:nvSpPr>
-        <p:spPr>
-          <a:xfrm>
-            <a:off x="868680" y="3931920"/>
-            <a:ext cx="10058400" cy="1188720"/>
+              <a:rPr lang="en-US" sz="2600" b="1" dirty="0">
+                <a:solidFill>
+                  <a:srgbClr val="3B2418"/>
+                </a:solidFill>
+                <a:latin typeface="Calibri" pitchFamily="34" charset="0"/>
+                <a:ea typeface="Calibri" pitchFamily="34" charset="-122"/>
+                <a:cs typeface="Calibri" pitchFamily="34" charset="-120"/>
+              </a:rPr>
+              <a:t>GIF o video: recorrido completo del sistema</a:t>
+            </a:r>
+            <a:endParaRPr lang="en-US" sz="2600" dirty="0"/>
+          </a:p>
+        </p:txBody>
+      </p:sp>
+      <p:sp>
+        <p:nvSpPr>
+          <p:cNvPr id="5" name="Shape 3"/>
+          <p:cNvSpPr/>
+          <p:nvPr/>
+        </p:nvSpPr>
+        <p:spPr>
+          <a:xfrm>
+            <a:off x="548640" y="1600200"/>
+            <a:ext cx="11064240" cy="3794760"/>
+          </a:xfrm>
+          <a:prstGeom prst="roundRect">
+            <a:avLst>
+              <a:gd name="adj" fmla="val 2410"/>
+            </a:avLst>
+          </a:prstGeom>
+          <a:solidFill>
+            <a:srgbClr val="EDE0C8"/>
+          </a:solidFill>
+          <a:ln w="25400">
+            <a:solidFill>
+              <a:srgbClr val="A85C32"/>
+            </a:solidFill>
+            <a:prstDash val="dash"/>
+          </a:ln>
+        </p:spPr>
+      </p:sp>
+      <p:sp>
+        <p:nvSpPr>
+          <p:cNvPr id="6" name="Text 4"/>
+          <p:cNvSpPr/>
+          <p:nvPr/>
+        </p:nvSpPr>
+        <p:spPr>
+          <a:xfrm>
+            <a:off x="548640" y="2377440"/>
+            <a:ext cx="11064240" cy="548640"/>
           </a:xfrm>
           <a:prstGeom prst="rect">
             <a:avLst/>
@@ -19055,34 +19212,34 @@
           <a:bodyPr wrap="square" rtlCol="0" anchor="ctr"/>
           <a:lstStyle/>
           <a:p>
-            <a:pPr indent="0" marL="0">
-              <a:buNone/>
-            </a:pPr>
-            <a:r>
-              <a:rPr lang="en-US" sz="3400" b="1" dirty="0">
-                <a:solidFill>
-                  <a:srgbClr val="FFFFFF"/>
-                </a:solidFill>
-                <a:latin typeface="Calibri" pitchFamily="34" charset="0"/>
-                <a:ea typeface="Calibri" pitchFamily="34" charset="-122"/>
-                <a:cs typeface="Calibri" pitchFamily="34" charset="-120"/>
-              </a:rPr>
-              <a:t>Repositorio</a:t>
-            </a:r>
-            <a:endParaRPr lang="en-US" sz="3400" dirty="0"/>
-          </a:p>
-        </p:txBody>
-      </p:sp>
-      <p:sp>
-        <p:nvSpPr>
-          <p:cNvPr id="5" name="Text 3"/>
-          <p:cNvSpPr/>
-          <p:nvPr/>
-        </p:nvSpPr>
-        <p:spPr>
-          <a:xfrm>
-            <a:off x="868680" y="4892040"/>
-            <a:ext cx="10058400" cy="457200"/>
+            <a:pPr algn="ctr" indent="0" marL="0">
+              <a:buNone/>
+            </a:pPr>
+            <a:r>
+              <a:rPr lang="en-US" sz="2400" b="1" dirty="0">
+                <a:solidFill>
+                  <a:srgbClr val="8B4513"/>
+                </a:solidFill>
+                <a:latin typeface="Calibri" pitchFamily="34" charset="0"/>
+                <a:ea typeface="Calibri" pitchFamily="34" charset="-122"/>
+                <a:cs typeface="Calibri" pitchFamily="34" charset="-120"/>
+              </a:rPr>
+              <a:t>📸  PEGÁ ACÁ TU CAPTURA / GIF</a:t>
+            </a:r>
+            <a:endParaRPr lang="en-US" sz="2400" dirty="0"/>
+          </a:p>
+        </p:txBody>
+      </p:sp>
+      <p:sp>
+        <p:nvSpPr>
+          <p:cNvPr id="7" name="Text 5"/>
+          <p:cNvSpPr/>
+          <p:nvPr/>
+        </p:nvSpPr>
+        <p:spPr>
+          <a:xfrm>
+            <a:off x="1188720" y="3017520"/>
+            <a:ext cx="9784080" cy="2103120"/>
           </a:xfrm>
           <a:prstGeom prst="rect">
             <a:avLst/>
@@ -19091,6 +19248,84 @@
           <a:ln/>
         </p:spPr>
         <p:txBody>
+          <a:bodyPr wrap="square" rtlCol="0" anchor="t"/>
+          <a:lstStyle/>
+          <a:p>
+            <a:pPr algn="ctr" indent="0" marL="0">
+              <a:buNone/>
+            </a:pPr>
+            <a:r>
+              <a:rPr lang="en-US" sz="1500" i="1" dirty="0">
+                <a:solidFill>
+                  <a:srgbClr val="2B2118"/>
+                </a:solidFill>
+                <a:latin typeface="Calibri" pitchFamily="34" charset="0"/>
+                <a:ea typeface="Calibri" pitchFamily="34" charset="-122"/>
+                <a:cs typeface="Calibri" pitchFamily="34" charset="-120"/>
+              </a:rPr>
+              <a:t>Grabación corta (GIF o video, 1-3 min) mostrando el flujo completo: home → catálogo → detalle con hojas extra → agregar al carrito → ver carrito → panel admin editando un producto → catálogo actualizándose solo por WebSockets.</a:t>
+            </a:r>
+            <a:endParaRPr lang="en-US" sz="1500" dirty="0"/>
+          </a:p>
+        </p:txBody>
+      </p:sp>
+      <p:sp>
+        <p:nvSpPr>
+          <p:cNvPr id="8" name="Text 6"/>
+          <p:cNvSpPr/>
+          <p:nvPr/>
+        </p:nvSpPr>
+        <p:spPr>
+          <a:xfrm>
+            <a:off x="640080" y="5532120"/>
+            <a:ext cx="10881360" cy="914400"/>
+          </a:xfrm>
+          <a:prstGeom prst="rect">
+            <a:avLst/>
+          </a:prstGeom>
+          <a:noFill/>
+          <a:ln/>
+        </p:spPr>
+        <p:txBody>
+          <a:bodyPr wrap="square" rtlCol="0" anchor="t"/>
+          <a:lstStyle/>
+          <a:p>
+            <a:pPr indent="0" marL="0">
+              <a:buNone/>
+            </a:pPr>
+            <a:r>
+              <a:rPr lang="en-US" sz="1250" dirty="0">
+                <a:solidFill>
+                  <a:srgbClr val="7A6A57"/>
+                </a:solidFill>
+                <a:latin typeface="Calibri" pitchFamily="34" charset="0"/>
+                <a:ea typeface="Calibri" pitchFamily="34" charset="-122"/>
+                <a:cs typeface="Calibri" pitchFamily="34" charset="-120"/>
+              </a:rPr>
+              <a:t>Cómo grabarlo: usá la grabadora de pantalla de Windows (Win+Alt+R) o una herramienta como ScreenToGif. Subilo a Drive/YouTube (no listado) y pegá el link o insertalo directamente en esta diapositiva.</a:t>
+            </a:r>
+            <a:endParaRPr lang="en-US" sz="1250" dirty="0"/>
+          </a:p>
+        </p:txBody>
+      </p:sp>
+      <p:sp>
+        <p:nvSpPr>
+          <p:cNvPr id="9" name="Text 7"/>
+          <p:cNvSpPr/>
+          <p:nvPr/>
+        </p:nvSpPr>
+        <p:spPr>
+          <a:xfrm>
+            <a:off x="457200" y="6537960"/>
+            <a:ext cx="8229600" cy="274320"/>
+          </a:xfrm>
+          <a:prstGeom prst="rect">
+            <a:avLst/>
+          </a:prstGeom>
+          <a:noFill/>
+          <a:ln/>
+        </p:spPr>
+        <p:txBody>
           <a:bodyPr wrap="square" rtlCol="0" anchor="ctr"/>
           <a:lstStyle/>
           <a:p>
@@ -19098,17 +19333,17 @@
               <a:buNone/>
             </a:pPr>
             <a:r>
-              <a:rPr lang="en-US" sz="1600" i="1" dirty="0">
-                <a:solidFill>
-                  <a:srgbClr val="E9DCC8"/>
-                </a:solidFill>
-                <a:latin typeface="Calibri" pitchFamily="34" charset="0"/>
-                <a:ea typeface="Calibri" pitchFamily="34" charset="-122"/>
-                <a:cs typeface="Calibri" pitchFamily="34" charset="-120"/>
-              </a:rPr>
-              <a:t>Referencia — no evaluado automáticamente, respaldo del desarrollo</a:t>
-            </a:r>
-            <a:endParaRPr lang="en-US" sz="1600" dirty="0"/>
+              <a:rPr lang="en-US" sz="900" dirty="0">
+                <a:solidFill>
+                  <a:srgbClr val="7A6A57"/>
+                </a:solidFill>
+                <a:latin typeface="Calibri" pitchFamily="34" charset="0"/>
+                <a:ea typeface="Calibri" pitchFamily="34" charset="-122"/>
+                <a:cs typeface="Calibri" pitchFamily="34" charset="-120"/>
+              </a:rPr>
+              <a:t>CAPTURE TUC — Proyecto final Backend, CoderHouse</a:t>
+            </a:r>
+            <a:endParaRPr lang="en-US" sz="900" dirty="0"/>
           </a:p>
         </p:txBody>
       </p:sp>
@@ -19152,69 +19387,28 @@
         </p:nvSpPr>
         <p:spPr>
           <a:xfrm>
-            <a:off x="548640" y="411480"/>
-            <a:ext cx="1965960" cy="329184"/>
-          </a:xfrm>
-          <a:prstGeom prst="roundRect">
-            <a:avLst>
-              <a:gd name="adj" fmla="val 22222"/>
-            </a:avLst>
-          </a:prstGeom>
-          <a:solidFill>
-            <a:srgbClr val="C6A369"/>
-          </a:solidFill>
-          <a:ln/>
-        </p:spPr>
-      </p:sp>
-      <p:sp>
-        <p:nvSpPr>
-          <p:cNvPr id="3" name="Text 1"/>
-          <p:cNvSpPr/>
-          <p:nvPr/>
-        </p:nvSpPr>
-        <p:spPr>
-          <a:xfrm>
-            <a:off x="548640" y="411480"/>
-            <a:ext cx="1965960" cy="329184"/>
+            <a:off x="0" y="0"/>
+            <a:ext cx="12188952" cy="6858000"/>
           </a:xfrm>
           <a:prstGeom prst="rect">
             <a:avLst/>
           </a:prstGeom>
-          <a:noFill/>
-          <a:ln/>
-        </p:spPr>
-        <p:txBody>
-          <a:bodyPr wrap="square" rtlCol="0" anchor="ctr"/>
-          <a:lstStyle/>
-          <a:p>
-            <a:pPr algn="ctr" indent="0" marL="0">
-              <a:buNone/>
-            </a:pPr>
-            <a:r>
-              <a:rPr lang="en-US" sz="1200" b="1" dirty="0">
-                <a:solidFill>
-                  <a:srgbClr val="3B2418"/>
-                </a:solidFill>
-                <a:latin typeface="Calibri" pitchFamily="34" charset="0"/>
-                <a:ea typeface="Calibri" pitchFamily="34" charset="-122"/>
-                <a:cs typeface="Calibri" pitchFamily="34" charset="-120"/>
-              </a:rPr>
-              <a:t>9 · Repositorio</a:t>
-            </a:r>
-            <a:endParaRPr lang="en-US" sz="1200" dirty="0"/>
-          </a:p>
-        </p:txBody>
-      </p:sp>
-      <p:sp>
-        <p:nvSpPr>
-          <p:cNvPr id="4" name="Text 2"/>
-          <p:cNvSpPr/>
-          <p:nvPr/>
-        </p:nvSpPr>
-        <p:spPr>
-          <a:xfrm>
-            <a:off x="548640" y="822960"/>
-            <a:ext cx="11064240" cy="640080"/>
+          <a:solidFill>
+            <a:srgbClr val="6B4226"/>
+          </a:solidFill>
+          <a:ln/>
+        </p:spPr>
+      </p:sp>
+      <p:sp>
+        <p:nvSpPr>
+          <p:cNvPr id="3" name="Text 1"/>
+          <p:cNvSpPr/>
+          <p:nvPr/>
+        </p:nvSpPr>
+        <p:spPr>
+          <a:xfrm>
+            <a:off x="822960" y="2103120"/>
+            <a:ext cx="2743200" cy="1828800"/>
           </a:xfrm>
           <a:prstGeom prst="rect">
             <a:avLst/>
@@ -19230,57 +19424,30 @@
               <a:buNone/>
             </a:pPr>
             <a:r>
-              <a:rPr lang="en-US" sz="2600" b="1" dirty="0">
-                <a:solidFill>
-                  <a:srgbClr val="3B2418"/>
-                </a:solidFill>
-                <a:latin typeface="Calibri" pitchFamily="34" charset="0"/>
-                <a:ea typeface="Calibri" pitchFamily="34" charset="-122"/>
-                <a:cs typeface="Calibri" pitchFamily="34" charset="-120"/>
-              </a:rPr>
-              <a:t>Repositorio en GitHub</a:t>
-            </a:r>
-            <a:endParaRPr lang="en-US" sz="2600" dirty="0"/>
-          </a:p>
-        </p:txBody>
-      </p:sp>
-      <p:sp>
-        <p:nvSpPr>
-          <p:cNvPr id="5" name="Shape 3"/>
-          <p:cNvSpPr/>
-          <p:nvPr/>
-        </p:nvSpPr>
-        <p:spPr>
-          <a:xfrm>
-            <a:off x="548640" y="1600200"/>
-            <a:ext cx="11064240" cy="3794760"/>
-          </a:xfrm>
-          <a:prstGeom prst="roundRect">
-            <a:avLst>
-              <a:gd name="adj" fmla="val 2410"/>
-            </a:avLst>
-          </a:prstGeom>
-          <a:solidFill>
-            <a:srgbClr val="EDE0C8"/>
-          </a:solidFill>
-          <a:ln w="25400">
-            <a:solidFill>
-              <a:srgbClr val="A85C32"/>
-            </a:solidFill>
-            <a:prstDash val="dash"/>
-          </a:ln>
-        </p:spPr>
-      </p:sp>
-      <p:sp>
-        <p:nvSpPr>
-          <p:cNvPr id="6" name="Text 4"/>
-          <p:cNvSpPr/>
-          <p:nvPr/>
-        </p:nvSpPr>
-        <p:spPr>
-          <a:xfrm>
-            <a:off x="548640" y="2377440"/>
-            <a:ext cx="11064240" cy="548640"/>
+              <a:rPr lang="en-US" sz="9000" b="1" dirty="0">
+                <a:solidFill>
+                  <a:srgbClr val="C6A369"/>
+                </a:solidFill>
+                <a:latin typeface="Calibri" pitchFamily="34" charset="0"/>
+                <a:ea typeface="Calibri" pitchFamily="34" charset="-122"/>
+                <a:cs typeface="Calibri" pitchFamily="34" charset="-120"/>
+              </a:rPr>
+              <a:t>9</a:t>
+            </a:r>
+            <a:endParaRPr lang="en-US" sz="9000" dirty="0"/>
+          </a:p>
+        </p:txBody>
+      </p:sp>
+      <p:sp>
+        <p:nvSpPr>
+          <p:cNvPr id="4" name="Text 2"/>
+          <p:cNvSpPr/>
+          <p:nvPr/>
+        </p:nvSpPr>
+        <p:spPr>
+          <a:xfrm>
+            <a:off x="868680" y="3931920"/>
+            <a:ext cx="10058400" cy="1188720"/>
           </a:xfrm>
           <a:prstGeom prst="rect">
             <a:avLst/>
@@ -19292,34 +19459,34 @@
           <a:bodyPr wrap="square" rtlCol="0" anchor="ctr"/>
           <a:lstStyle/>
           <a:p>
-            <a:pPr algn="ctr" indent="0" marL="0">
-              <a:buNone/>
-            </a:pPr>
-            <a:r>
-              <a:rPr lang="en-US" sz="2400" b="1" dirty="0">
-                <a:solidFill>
-                  <a:srgbClr val="8B4513"/>
-                </a:solidFill>
-                <a:latin typeface="Calibri" pitchFamily="34" charset="0"/>
-                <a:ea typeface="Calibri" pitchFamily="34" charset="-122"/>
-                <a:cs typeface="Calibri" pitchFamily="34" charset="-120"/>
-              </a:rPr>
-              <a:t>📸  PEGÁ ACÁ TU CAPTURA / GIF</a:t>
-            </a:r>
-            <a:endParaRPr lang="en-US" sz="2400" dirty="0"/>
-          </a:p>
-        </p:txBody>
-      </p:sp>
-      <p:sp>
-        <p:nvSpPr>
-          <p:cNvPr id="7" name="Text 5"/>
-          <p:cNvSpPr/>
-          <p:nvPr/>
-        </p:nvSpPr>
-        <p:spPr>
-          <a:xfrm>
-            <a:off x="1188720" y="3017520"/>
-            <a:ext cx="9784080" cy="2103120"/>
+            <a:pPr indent="0" marL="0">
+              <a:buNone/>
+            </a:pPr>
+            <a:r>
+              <a:rPr lang="en-US" sz="3400" b="1" dirty="0">
+                <a:solidFill>
+                  <a:srgbClr val="FFFFFF"/>
+                </a:solidFill>
+                <a:latin typeface="Calibri" pitchFamily="34" charset="0"/>
+                <a:ea typeface="Calibri" pitchFamily="34" charset="-122"/>
+                <a:cs typeface="Calibri" pitchFamily="34" charset="-120"/>
+              </a:rPr>
+              <a:t>Repositorio</a:t>
+            </a:r>
+            <a:endParaRPr lang="en-US" sz="3400" dirty="0"/>
+          </a:p>
+        </p:txBody>
+      </p:sp>
+      <p:sp>
+        <p:nvSpPr>
+          <p:cNvPr id="5" name="Text 3"/>
+          <p:cNvSpPr/>
+          <p:nvPr/>
+        </p:nvSpPr>
+        <p:spPr>
+          <a:xfrm>
+            <a:off x="868680" y="4892040"/>
+            <a:ext cx="10058400" cy="457200"/>
           </a:xfrm>
           <a:prstGeom prst="rect">
             <a:avLst/>
@@ -19328,130 +19495,6 @@
           <a:ln/>
         </p:spPr>
         <p:txBody>
-          <a:bodyPr wrap="square" rtlCol="0" anchor="t"/>
-          <a:lstStyle/>
-          <a:p>
-            <a:pPr algn="ctr" indent="0" marL="0">
-              <a:buNone/>
-            </a:pPr>
-            <a:r>
-              <a:rPr lang="en-US" sz="1500" i="1" dirty="0">
-                <a:solidFill>
-                  <a:srgbClr val="2B2118"/>
-                </a:solidFill>
-                <a:latin typeface="Calibri" pitchFamily="34" charset="0"/>
-                <a:ea typeface="Calibri" pitchFamily="34" charset="-122"/>
-                <a:cs typeface="Calibri" pitchFamily="34" charset="-120"/>
-              </a:rPr>
-              <a:t>Link al repositorio completo:</a:t>
-            </a:r>
-            <a:endParaRPr lang="en-US" sz="1500" dirty="0"/>
-          </a:p>
-          <a:p>
-            <a:pPr algn="ctr" indent="0" marL="0">
-              <a:buNone/>
-            </a:pPr>
-            <a:endParaRPr lang="en-US" sz="1500" dirty="0"/>
-          </a:p>
-          <a:p>
-            <a:pPr algn="ctr" indent="0" marL="0">
-              <a:buNone/>
-            </a:pPr>
-            <a:r>
-              <a:rPr lang="en-US" sz="1500" i="1" dirty="0">
-                <a:solidFill>
-                  <a:srgbClr val="2B2118"/>
-                </a:solidFill>
-                <a:latin typeface="Calibri" pitchFamily="34" charset="0"/>
-                <a:ea typeface="Calibri" pitchFamily="34" charset="-122"/>
-                <a:cs typeface="Calibri" pitchFamily="34" charset="-120"/>
-              </a:rPr>
-              <a:t>https://github.com/________/capture-tuc</a:t>
-            </a:r>
-            <a:endParaRPr lang="en-US" sz="1500" dirty="0"/>
-          </a:p>
-          <a:p>
-            <a:pPr algn="ctr" indent="0" marL="0">
-              <a:buNone/>
-            </a:pPr>
-            <a:endParaRPr lang="en-US" sz="1500" dirty="0"/>
-          </a:p>
-          <a:p>
-            <a:pPr algn="ctr" indent="0" marL="0">
-              <a:buNone/>
-            </a:pPr>
-            <a:r>
-              <a:rPr lang="en-US" sz="1500" i="1" dirty="0">
-                <a:solidFill>
-                  <a:srgbClr val="2B2118"/>
-                </a:solidFill>
-                <a:latin typeface="Calibri" pitchFamily="34" charset="0"/>
-                <a:ea typeface="Calibri" pitchFamily="34" charset="-122"/>
-                <a:cs typeface="Calibri" pitchFamily="34" charset="-120"/>
-              </a:rPr>
-              <a:t>(pegalo acá una vez que lo subas con GitHub Desktop)</a:t>
-            </a:r>
-            <a:endParaRPr lang="en-US" sz="1500" dirty="0"/>
-          </a:p>
-        </p:txBody>
-      </p:sp>
-      <p:sp>
-        <p:nvSpPr>
-          <p:cNvPr id="8" name="Text 6"/>
-          <p:cNvSpPr/>
-          <p:nvPr/>
-        </p:nvSpPr>
-        <p:spPr>
-          <a:xfrm>
-            <a:off x="640080" y="5532120"/>
-            <a:ext cx="10881360" cy="914400"/>
-          </a:xfrm>
-          <a:prstGeom prst="rect">
-            <a:avLst/>
-          </a:prstGeom>
-          <a:noFill/>
-          <a:ln/>
-        </p:spPr>
-        <p:txBody>
-          <a:bodyPr wrap="square" rtlCol="0" anchor="t"/>
-          <a:lstStyle/>
-          <a:p>
-            <a:pPr indent="0" marL="0">
-              <a:buNone/>
-            </a:pPr>
-            <a:r>
-              <a:rPr lang="en-US" sz="1250" dirty="0">
-                <a:solidFill>
-                  <a:srgbClr val="7A6A57"/>
-                </a:solidFill>
-                <a:latin typeface="Calibri" pitchFamily="34" charset="0"/>
-                <a:ea typeface="Calibri" pitchFamily="34" charset="-122"/>
-                <a:cs typeface="Calibri" pitchFamily="34" charset="-120"/>
-              </a:rPr>
-              <a:t>El repo local ya está inicializado y tiene el primer commit listo. Usá GitHub Desktop (ya lo tenés instalado) para publicarlo: "Publish repository" → elegí público o privado → listo.</a:t>
-            </a:r>
-            <a:endParaRPr lang="en-US" sz="1250" dirty="0"/>
-          </a:p>
-        </p:txBody>
-      </p:sp>
-      <p:sp>
-        <p:nvSpPr>
-          <p:cNvPr id="9" name="Text 7"/>
-          <p:cNvSpPr/>
-          <p:nvPr/>
-        </p:nvSpPr>
-        <p:spPr>
-          <a:xfrm>
-            <a:off x="457200" y="6537960"/>
-            <a:ext cx="8229600" cy="274320"/>
-          </a:xfrm>
-          <a:prstGeom prst="rect">
-            <a:avLst/>
-          </a:prstGeom>
-          <a:noFill/>
-          <a:ln/>
-        </p:spPr>
-        <p:txBody>
           <a:bodyPr wrap="square" rtlCol="0" anchor="ctr"/>
           <a:lstStyle/>
           <a:p>
@@ -19459,17 +19502,17 @@
               <a:buNone/>
             </a:pPr>
             <a:r>
-              <a:rPr lang="en-US" sz="900" dirty="0">
-                <a:solidFill>
-                  <a:srgbClr val="7A6A57"/>
-                </a:solidFill>
-                <a:latin typeface="Calibri" pitchFamily="34" charset="0"/>
-                <a:ea typeface="Calibri" pitchFamily="34" charset="-122"/>
-                <a:cs typeface="Calibri" pitchFamily="34" charset="-120"/>
-              </a:rPr>
-              <a:t>CAPTURE TUC — Proyecto final Backend, CoderHouse</a:t>
-            </a:r>
-            <a:endParaRPr lang="en-US" sz="900" dirty="0"/>
+              <a:rPr lang="en-US" sz="1600" i="1" dirty="0">
+                <a:solidFill>
+                  <a:srgbClr val="E9DCC8"/>
+                </a:solidFill>
+                <a:latin typeface="Calibri" pitchFamily="34" charset="0"/>
+                <a:ea typeface="Calibri" pitchFamily="34" charset="-122"/>
+                <a:cs typeface="Calibri" pitchFamily="34" charset="-120"/>
+              </a:rPr>
+              <a:t>Referencia — no evaluado automáticamente, respaldo del desarrollo</a:t>
+            </a:r>
+            <a:endParaRPr lang="en-US" sz="1600" dirty="0"/>
           </a:p>
         </p:txBody>
       </p:sp>
@@ -19513,28 +19556,69 @@
         </p:nvSpPr>
         <p:spPr>
           <a:xfrm>
-            <a:off x="0" y="0"/>
-            <a:ext cx="12188952" cy="6858000"/>
+            <a:off x="548640" y="411480"/>
+            <a:ext cx="1965960" cy="329184"/>
+          </a:xfrm>
+          <a:prstGeom prst="roundRect">
+            <a:avLst>
+              <a:gd name="adj" fmla="val 22222"/>
+            </a:avLst>
+          </a:prstGeom>
+          <a:solidFill>
+            <a:srgbClr val="C6A369"/>
+          </a:solidFill>
+          <a:ln/>
+        </p:spPr>
+      </p:sp>
+      <p:sp>
+        <p:nvSpPr>
+          <p:cNvPr id="3" name="Text 1"/>
+          <p:cNvSpPr/>
+          <p:nvPr/>
+        </p:nvSpPr>
+        <p:spPr>
+          <a:xfrm>
+            <a:off x="548640" y="411480"/>
+            <a:ext cx="1965960" cy="329184"/>
           </a:xfrm>
           <a:prstGeom prst="rect">
             <a:avLst/>
           </a:prstGeom>
-          <a:solidFill>
-            <a:srgbClr val="6B4226"/>
-          </a:solidFill>
-          <a:ln/>
-        </p:spPr>
-      </p:sp>
-      <p:sp>
-        <p:nvSpPr>
-          <p:cNvPr id="3" name="Text 1"/>
-          <p:cNvSpPr/>
-          <p:nvPr/>
-        </p:nvSpPr>
-        <p:spPr>
-          <a:xfrm>
-            <a:off x="822960" y="2103120"/>
-            <a:ext cx="2743200" cy="1828800"/>
+          <a:noFill/>
+          <a:ln/>
+        </p:spPr>
+        <p:txBody>
+          <a:bodyPr wrap="square" rtlCol="0" anchor="ctr"/>
+          <a:lstStyle/>
+          <a:p>
+            <a:pPr algn="ctr" indent="0" marL="0">
+              <a:buNone/>
+            </a:pPr>
+            <a:r>
+              <a:rPr lang="en-US" sz="1200" b="1" dirty="0">
+                <a:solidFill>
+                  <a:srgbClr val="3B2418"/>
+                </a:solidFill>
+                <a:latin typeface="Calibri" pitchFamily="34" charset="0"/>
+                <a:ea typeface="Calibri" pitchFamily="34" charset="-122"/>
+                <a:cs typeface="Calibri" pitchFamily="34" charset="-120"/>
+              </a:rPr>
+              <a:t>9 · Repositorio</a:t>
+            </a:r>
+            <a:endParaRPr lang="en-US" sz="1200" dirty="0"/>
+          </a:p>
+        </p:txBody>
+      </p:sp>
+      <p:sp>
+        <p:nvSpPr>
+          <p:cNvPr id="4" name="Text 2"/>
+          <p:cNvSpPr/>
+          <p:nvPr/>
+        </p:nvSpPr>
+        <p:spPr>
+          <a:xfrm>
+            <a:off x="548640" y="822960"/>
+            <a:ext cx="11064240" cy="640080"/>
           </a:xfrm>
           <a:prstGeom prst="rect">
             <a:avLst/>
@@ -19550,30 +19634,57 @@
               <a:buNone/>
             </a:pPr>
             <a:r>
-              <a:rPr lang="en-US" sz="9000" b="1" dirty="0">
-                <a:solidFill>
-                  <a:srgbClr val="C6A369"/>
-                </a:solidFill>
-                <a:latin typeface="Calibri" pitchFamily="34" charset="0"/>
-                <a:ea typeface="Calibri" pitchFamily="34" charset="-122"/>
-                <a:cs typeface="Calibri" pitchFamily="34" charset="-120"/>
-              </a:rPr>
-              <a:t>10</a:t>
-            </a:r>
-            <a:endParaRPr lang="en-US" sz="9000" dirty="0"/>
-          </a:p>
-        </p:txBody>
-      </p:sp>
-      <p:sp>
-        <p:nvSpPr>
-          <p:cNvPr id="4" name="Text 2"/>
-          <p:cNvSpPr/>
-          <p:nvPr/>
-        </p:nvSpPr>
-        <p:spPr>
-          <a:xfrm>
-            <a:off x="868680" y="3931920"/>
-            <a:ext cx="10058400" cy="1188720"/>
+              <a:rPr lang="en-US" sz="2800" b="1" dirty="0">
+                <a:solidFill>
+                  <a:srgbClr val="3B2418"/>
+                </a:solidFill>
+                <a:latin typeface="Calibri" pitchFamily="34" charset="0"/>
+                <a:ea typeface="Calibri" pitchFamily="34" charset="-122"/>
+                <a:cs typeface="Calibri" pitchFamily="34" charset="-120"/>
+              </a:rPr>
+              <a:t>Repositorio en GitHub</a:t>
+            </a:r>
+            <a:endParaRPr lang="en-US" sz="2800" dirty="0"/>
+          </a:p>
+        </p:txBody>
+      </p:sp>
+      <p:sp>
+        <p:nvSpPr>
+          <p:cNvPr id="5" name="Shape 3"/>
+          <p:cNvSpPr/>
+          <p:nvPr/>
+        </p:nvSpPr>
+        <p:spPr>
+          <a:xfrm>
+            <a:off x="548640" y="1828800"/>
+            <a:ext cx="11064240" cy="1737360"/>
+          </a:xfrm>
+          <a:prstGeom prst="roundRect">
+            <a:avLst>
+              <a:gd name="adj" fmla="val 5263"/>
+            </a:avLst>
+          </a:prstGeom>
+          <a:solidFill>
+            <a:srgbClr val="FBF6EC"/>
+          </a:solidFill>
+          <a:ln w="12700">
+            <a:solidFill>
+              <a:srgbClr val="D9C7A8"/>
+            </a:solidFill>
+            <a:prstDash val="solid"/>
+          </a:ln>
+        </p:spPr>
+      </p:sp>
+      <p:sp>
+        <p:nvSpPr>
+          <p:cNvPr id="6" name="Text 4"/>
+          <p:cNvSpPr/>
+          <p:nvPr/>
+        </p:nvSpPr>
+        <p:spPr>
+          <a:xfrm>
+            <a:off x="914400" y="2057400"/>
+            <a:ext cx="10332720" cy="457200"/>
           </a:xfrm>
           <a:prstGeom prst="rect">
             <a:avLst/>
@@ -19589,30 +19700,32 @@
               <a:buNone/>
             </a:pPr>
             <a:r>
-              <a:rPr lang="en-US" sz="3400" b="1" dirty="0">
-                <a:solidFill>
-                  <a:srgbClr val="FFFFFF"/>
-                </a:solidFill>
-                <a:latin typeface="Calibri" pitchFamily="34" charset="0"/>
-                <a:ea typeface="Calibri" pitchFamily="34" charset="-122"/>
-                <a:cs typeface="Calibri" pitchFamily="34" charset="-120"/>
-              </a:rPr>
-              <a:t>Cierre del proyecto</a:t>
-            </a:r>
-            <a:endParaRPr lang="en-US" sz="3400" dirty="0"/>
-          </a:p>
-        </p:txBody>
-      </p:sp>
-      <p:sp>
-        <p:nvSpPr>
-          <p:cNvPr id="5" name="Text 3"/>
-          <p:cNvSpPr/>
-          <p:nvPr/>
-        </p:nvSpPr>
-        <p:spPr>
-          <a:xfrm>
-            <a:off x="868680" y="4892040"/>
-            <a:ext cx="10058400" cy="457200"/>
+              <a:rPr lang="en-US" sz="1500" dirty="0">
+                <a:solidFill>
+                  <a:srgbClr val="2B2118"/>
+                </a:solidFill>
+                <a:latin typeface="Calibri" pitchFamily="34" charset="0"/>
+                <a:ea typeface="Calibri" pitchFamily="34" charset="-122"/>
+                <a:cs typeface="Calibri" pitchFamily="34" charset="-120"/>
+              </a:rPr>
+              <a:t>Código fuente completo, historial de commits y respaldo del desarrollo:</a:t>
+            </a:r>
+            <a:endParaRPr lang="en-US" sz="1500" dirty="0"/>
+          </a:p>
+        </p:txBody>
+      </p:sp>
+      <p:sp>
+        <p:nvSpPr>
+          <p:cNvPr id="7" name="Text 5">
+            <a:hlinkClick r:id="rId1" tooltip=""/>
+          </p:cNvPr>
+          <p:cNvSpPr/>
+          <p:nvPr/>
+        </p:nvSpPr>
+        <p:spPr>
+          <a:xfrm>
+            <a:off x="914400" y="2514600"/>
+            <a:ext cx="10332720" cy="548640"/>
           </a:xfrm>
           <a:prstGeom prst="rect">
             <a:avLst/>
@@ -19628,17 +19741,148 @@
               <a:buNone/>
             </a:pPr>
             <a:r>
-              <a:rPr lang="en-US" sz="1600" i="1" dirty="0">
-                <a:solidFill>
-                  <a:srgbClr val="E9DCC8"/>
-                </a:solidFill>
-                <a:latin typeface="Calibri" pitchFamily="34" charset="0"/>
-                <a:ea typeface="Calibri" pitchFamily="34" charset="-122"/>
-                <a:cs typeface="Calibri" pitchFamily="34" charset="-120"/>
-              </a:rPr>
-              <a:t>Dificultades, soluciones y mejoras futuras</a:t>
-            </a:r>
-            <a:endParaRPr lang="en-US" sz="1600" dirty="0"/>
+              <a:rPr lang="en-US" sz="2200" b="1" u="sng" dirty="0">
+                <a:solidFill>
+                  <a:srgbClr val="6B4226"/>
+                </a:solidFill>
+                <a:latin typeface="Calibri" pitchFamily="34" charset="0"/>
+                <a:ea typeface="Calibri" pitchFamily="34" charset="-122"/>
+                <a:cs typeface="Calibri" pitchFamily="34" charset="-120"/>
+                <a:hlinkClick r:id="rId1" invalidUrl="" action="" tgtFrame="" tooltip="" history="1" highlightClick="0" endSnd="0">
+                  <a:extLst>
+                    <a:ext uri="{A12FA001-AC4F-418D-AE19-62706E023703}">
+                      <ahyp:hlinkClr xmlns:ahyp="http://schemas.microsoft.com/office/drawing/2018/hyperlinkcolor" val="tx"/>
+                    </a:ext>
+                  </a:extLst>
+                </a:hlinkClick>
+              </a:rPr>
+              <a:t>github.com/lucianagarciagalo894-dot/Capturetuc</a:t>
+            </a:r>
+            <a:endParaRPr lang="en-US" sz="2200" dirty="0"/>
+          </a:p>
+        </p:txBody>
+      </p:sp>
+      <p:sp>
+        <p:nvSpPr>
+          <p:cNvPr id="8" name="Text 6"/>
+          <p:cNvSpPr/>
+          <p:nvPr/>
+        </p:nvSpPr>
+        <p:spPr>
+          <a:xfrm>
+            <a:off x="640080" y="3840480"/>
+            <a:ext cx="10881360" cy="1828800"/>
+          </a:xfrm>
+          <a:prstGeom prst="rect">
+            <a:avLst/>
+          </a:prstGeom>
+          <a:noFill/>
+          <a:ln/>
+        </p:spPr>
+        <p:txBody>
+          <a:bodyPr wrap="square" rtlCol="0" anchor="t"/>
+          <a:lstStyle/>
+          <a:p>
+            <a:pPr marL="342900" indent="-342900">
+              <a:lnSpc>
+                <a:spcPct val="125000"/>
+              </a:lnSpc>
+              <a:buSzPct val="100000"/>
+              <a:buChar char="•"/>
+            </a:pPr>
+            <a:r>
+              <a:rPr lang="en-US" sz="1400" dirty="0">
+                <a:solidFill>
+                  <a:srgbClr val="2B2118"/>
+                </a:solidFill>
+                <a:latin typeface="Calibri" pitchFamily="34" charset="0"/>
+                <a:ea typeface="Calibri" pitchFamily="34" charset="-122"/>
+                <a:cs typeface="Calibri" pitchFamily="34" charset="-120"/>
+              </a:rPr>
+              <a:t>No es evaluado directamente por la herramienta automática de corrección, pero debe existir como respaldo del desarrollo (según la consigna).</a:t>
+            </a:r>
+            <a:endParaRPr lang="en-US" sz="1400" dirty="0"/>
+          </a:p>
+          <a:p>
+            <a:pPr marL="342900" indent="-342900">
+              <a:lnSpc>
+                <a:spcPct val="125000"/>
+              </a:lnSpc>
+              <a:buSzPct val="100000"/>
+              <a:buChar char="•"/>
+            </a:pPr>
+            <a:r>
+              <a:rPr lang="en-US" sz="1400" dirty="0">
+                <a:solidFill>
+                  <a:srgbClr val="2B2118"/>
+                </a:solidFill>
+                <a:latin typeface="Calibri" pitchFamily="34" charset="0"/>
+                <a:ea typeface="Calibri" pitchFamily="34" charset="-122"/>
+                <a:cs typeface="Calibri" pitchFamily="34" charset="-120"/>
+              </a:rPr>
+              <a:t>Repositorio público, publicado con GitHub Desktop.</a:t>
+            </a:r>
+            <a:endParaRPr lang="en-US" sz="1400" dirty="0"/>
+          </a:p>
+          <a:p>
+            <a:pPr marL="342900" indent="-342900">
+              <a:lnSpc>
+                <a:spcPct val="125000"/>
+              </a:lnSpc>
+              <a:buSzPct val="100000"/>
+              <a:buChar char="•"/>
+            </a:pPr>
+            <a:r>
+              <a:rPr lang="en-US" sz="1400" dirty="0">
+                <a:solidFill>
+                  <a:srgbClr val="2B2118"/>
+                </a:solidFill>
+                <a:latin typeface="Calibri" pitchFamily="34" charset="0"/>
+                <a:ea typeface="Calibri" pitchFamily="34" charset="-122"/>
+                <a:cs typeface="Calibri" pitchFamily="34" charset="-120"/>
+              </a:rPr>
+              <a:t>Incluye todo el código: backend, vistas, modelos, DAO, middlewares, Postman y esta misma presentación.</a:t>
+            </a:r>
+            <a:endParaRPr lang="en-US" sz="1400" dirty="0"/>
+          </a:p>
+        </p:txBody>
+      </p:sp>
+      <p:sp>
+        <p:nvSpPr>
+          <p:cNvPr id="9" name="Text 7"/>
+          <p:cNvSpPr/>
+          <p:nvPr/>
+        </p:nvSpPr>
+        <p:spPr>
+          <a:xfrm>
+            <a:off x="457200" y="6537960"/>
+            <a:ext cx="8229600" cy="274320"/>
+          </a:xfrm>
+          <a:prstGeom prst="rect">
+            <a:avLst/>
+          </a:prstGeom>
+          <a:noFill/>
+          <a:ln/>
+        </p:spPr>
+        <p:txBody>
+          <a:bodyPr wrap="square" rtlCol="0" anchor="ctr"/>
+          <a:lstStyle/>
+          <a:p>
+            <a:pPr indent="0" marL="0">
+              <a:buNone/>
+            </a:pPr>
+            <a:r>
+              <a:rPr lang="en-US" sz="900" dirty="0">
+                <a:solidFill>
+                  <a:srgbClr val="7A6A57"/>
+                </a:solidFill>
+                <a:latin typeface="Calibri" pitchFamily="34" charset="0"/>
+                <a:ea typeface="Calibri" pitchFamily="34" charset="-122"/>
+                <a:cs typeface="Calibri" pitchFamily="34" charset="-120"/>
+              </a:rPr>
+              <a:t>CAPTURE TUC — Proyecto final Backend, CoderHouse</a:t>
+            </a:r>
+            <a:endParaRPr lang="en-US" sz="900" dirty="0"/>
           </a:p>
         </p:txBody>
       </p:sp>
@@ -19982,69 +20226,28 @@
         </p:nvSpPr>
         <p:spPr>
           <a:xfrm>
-            <a:off x="548640" y="411480"/>
-            <a:ext cx="1563624" cy="329184"/>
-          </a:xfrm>
-          <a:prstGeom prst="roundRect">
-            <a:avLst>
-              <a:gd name="adj" fmla="val 22222"/>
-            </a:avLst>
-          </a:prstGeom>
-          <a:solidFill>
-            <a:srgbClr val="C6A369"/>
-          </a:solidFill>
-          <a:ln/>
-        </p:spPr>
-      </p:sp>
-      <p:sp>
-        <p:nvSpPr>
-          <p:cNvPr id="3" name="Text 1"/>
-          <p:cNvSpPr/>
-          <p:nvPr/>
-        </p:nvSpPr>
-        <p:spPr>
-          <a:xfrm>
-            <a:off x="548640" y="411480"/>
-            <a:ext cx="1563624" cy="329184"/>
+            <a:off x="0" y="0"/>
+            <a:ext cx="12188952" cy="6858000"/>
           </a:xfrm>
           <a:prstGeom prst="rect">
             <a:avLst/>
           </a:prstGeom>
-          <a:noFill/>
-          <a:ln/>
-        </p:spPr>
-        <p:txBody>
-          <a:bodyPr wrap="square" rtlCol="0" anchor="ctr"/>
-          <a:lstStyle/>
-          <a:p>
-            <a:pPr algn="ctr" indent="0" marL="0">
-              <a:buNone/>
-            </a:pPr>
-            <a:r>
-              <a:rPr lang="en-US" sz="1200" b="1" dirty="0">
-                <a:solidFill>
-                  <a:srgbClr val="3B2418"/>
-                </a:solidFill>
-                <a:latin typeface="Calibri" pitchFamily="34" charset="0"/>
-                <a:ea typeface="Calibri" pitchFamily="34" charset="-122"/>
-                <a:cs typeface="Calibri" pitchFamily="34" charset="-120"/>
-              </a:rPr>
-              <a:t>10 · Cierre</a:t>
-            </a:r>
-            <a:endParaRPr lang="en-US" sz="1200" dirty="0"/>
-          </a:p>
-        </p:txBody>
-      </p:sp>
-      <p:sp>
-        <p:nvSpPr>
-          <p:cNvPr id="4" name="Text 2"/>
-          <p:cNvSpPr/>
-          <p:nvPr/>
-        </p:nvSpPr>
-        <p:spPr>
-          <a:xfrm>
-            <a:off x="548640" y="822960"/>
-            <a:ext cx="11064240" cy="731520"/>
+          <a:solidFill>
+            <a:srgbClr val="6B4226"/>
+          </a:solidFill>
+          <a:ln/>
+        </p:spPr>
+      </p:sp>
+      <p:sp>
+        <p:nvSpPr>
+          <p:cNvPr id="3" name="Text 1"/>
+          <p:cNvSpPr/>
+          <p:nvPr/>
+        </p:nvSpPr>
+        <p:spPr>
+          <a:xfrm>
+            <a:off x="822960" y="2103120"/>
+            <a:ext cx="2743200" cy="1828800"/>
           </a:xfrm>
           <a:prstGeom prst="rect">
             <a:avLst/>
@@ -20060,53 +20263,30 @@
               <a:buNone/>
             </a:pPr>
             <a:r>
-              <a:rPr lang="en-US" sz="2800" b="1" dirty="0">
-                <a:solidFill>
-                  <a:srgbClr val="3B2418"/>
-                </a:solidFill>
-                <a:latin typeface="Calibri" pitchFamily="34" charset="0"/>
-                <a:ea typeface="Calibri" pitchFamily="34" charset="-122"/>
-                <a:cs typeface="Calibri" pitchFamily="34" charset="-120"/>
-              </a:rPr>
-              <a:t>Dificultades encontradas y soluciones</a:t>
-            </a:r>
-            <a:endParaRPr lang="en-US" sz="2800" dirty="0"/>
-          </a:p>
-        </p:txBody>
-      </p:sp>
-      <p:sp>
-        <p:nvSpPr>
-          <p:cNvPr id="5" name="Shape 3"/>
-          <p:cNvSpPr/>
-          <p:nvPr/>
-        </p:nvSpPr>
-        <p:spPr>
-          <a:xfrm>
-            <a:off x="548640" y="1508760"/>
-            <a:ext cx="11064240" cy="0"/>
-          </a:xfrm>
-          <a:prstGeom prst="line">
-            <a:avLst/>
-          </a:prstGeom>
-          <a:noFill/>
-          <a:ln w="19050">
-            <a:solidFill>
-              <a:srgbClr val="D9C7A8"/>
-            </a:solidFill>
-            <a:prstDash val="solid"/>
-          </a:ln>
-        </p:spPr>
-      </p:sp>
-      <p:sp>
-        <p:nvSpPr>
-          <p:cNvPr id="6" name="Text 4"/>
-          <p:cNvSpPr/>
-          <p:nvPr/>
-        </p:nvSpPr>
-        <p:spPr>
-          <a:xfrm>
-            <a:off x="640080" y="1783080"/>
-            <a:ext cx="10881360" cy="4206240"/>
+              <a:rPr lang="en-US" sz="9000" b="1" dirty="0">
+                <a:solidFill>
+                  <a:srgbClr val="C6A369"/>
+                </a:solidFill>
+                <a:latin typeface="Calibri" pitchFamily="34" charset="0"/>
+                <a:ea typeface="Calibri" pitchFamily="34" charset="-122"/>
+                <a:cs typeface="Calibri" pitchFamily="34" charset="-120"/>
+              </a:rPr>
+              <a:t>10</a:t>
+            </a:r>
+            <a:endParaRPr lang="en-US" sz="9000" dirty="0"/>
+          </a:p>
+        </p:txBody>
+      </p:sp>
+      <p:sp>
+        <p:nvSpPr>
+          <p:cNvPr id="4" name="Text 2"/>
+          <p:cNvSpPr/>
+          <p:nvPr/>
+        </p:nvSpPr>
+        <p:spPr>
+          <a:xfrm>
+            <a:off x="868680" y="3931920"/>
+            <a:ext cx="10058400" cy="1188720"/>
           </a:xfrm>
           <a:prstGeom prst="rect">
             <a:avLst/>
@@ -20115,143 +20295,37 @@
           <a:ln/>
         </p:spPr>
         <p:txBody>
-          <a:bodyPr wrap="square" rtlCol="0" anchor="t"/>
-          <a:lstStyle/>
-          <a:p>
-            <a:pPr marL="342900" indent="-342900">
-              <a:lnSpc>
-                <a:spcPct val="125000"/>
-              </a:lnSpc>
-              <a:buSzPct val="100000"/>
-              <a:buChar char="•"/>
-            </a:pPr>
-            <a:r>
-              <a:rPr lang="en-US" sz="1700" b="1" dirty="0">
-                <a:solidFill>
-                  <a:srgbClr val="3B2418"/>
-                </a:solidFill>
-                <a:latin typeface="Calibri" pitchFamily="34" charset="0"/>
-                <a:ea typeface="Calibri" pitchFamily="34" charset="-122"/>
-                <a:cs typeface="Calibri" pitchFamily="34" charset="-120"/>
-              </a:rPr>
-              <a:t>Conexión a MongoDB Atlas fallaba con "querySrv ECONNREFUSED".</a:t>
-            </a:r>
-            <a:endParaRPr lang="en-US" sz="1700" dirty="0"/>
-          </a:p>
-          <a:p>
-            <a:pPr lvl="1" indent="0" marL="0">
-              <a:lnSpc>
-                <a:spcPct val="125000"/>
-              </a:lnSpc>
-              <a:buNone/>
-            </a:pPr>
-            <a:r>
-              <a:rPr lang="en-US" sz="1450" dirty="0">
-                <a:solidFill>
-                  <a:srgbClr val="2B2118"/>
-                </a:solidFill>
-                <a:latin typeface="Calibri" pitchFamily="34" charset="0"/>
-                <a:ea typeface="Calibri" pitchFamily="34" charset="-122"/>
-                <a:cs typeface="Calibri" pitchFamily="34" charset="-120"/>
-              </a:rPr>
-              <a:t>El DNS local de la red (127.0.0.1) no resolvía los registros SRV que usa mongodb+srv://. Se solucionó apuntando la resolución DNS del proceso de Node a un servidor público (8.8.8.8), sin tocar la red del sistema ni la cadena de conexión (src/config/db.js).</a:t>
-            </a:r>
-            <a:endParaRPr lang="en-US" sz="1700" dirty="0"/>
-          </a:p>
-          <a:p>
-            <a:pPr marL="342900" indent="-342900">
-              <a:lnSpc>
-                <a:spcPct val="125000"/>
-              </a:lnSpc>
-              <a:buSzPct val="100000"/>
-              <a:buChar char="•"/>
-            </a:pPr>
-            <a:r>
-              <a:rPr lang="en-US" sz="1700" b="1" dirty="0">
-                <a:solidFill>
-                  <a:srgbClr val="3B2418"/>
-                </a:solidFill>
-                <a:latin typeface="Calibri" pitchFamily="34" charset="0"/>
-                <a:ea typeface="Calibri" pitchFamily="34" charset="-122"/>
-                <a:cs typeface="Calibri" pitchFamily="34" charset="-120"/>
-              </a:rPr>
-              <a:t>Simplificar el modelo sin perder de vista la consigna académica.</a:t>
-            </a:r>
-            <a:endParaRPr lang="en-US" sz="1700" dirty="0"/>
-          </a:p>
-          <a:p>
-            <a:pPr lvl="1" indent="0" marL="0">
-              <a:lnSpc>
-                <a:spcPct val="125000"/>
-              </a:lnSpc>
-              <a:buNone/>
-            </a:pPr>
-            <a:r>
-              <a:rPr lang="en-US" sz="1450" dirty="0">
-                <a:solidFill>
-                  <a:srgbClr val="2B2118"/>
-                </a:solidFill>
-                <a:latin typeface="Calibri" pitchFamily="34" charset="0"/>
-                <a:ea typeface="Calibri" pitchFamily="34" charset="-122"/>
-                <a:cs typeface="Calibri" pitchFamily="34" charset="-120"/>
-              </a:rPr>
-              <a:t>El negocio real no usaba campos como "código" o "material". Se simplificó el modelo a pedido del negocio, documentando en el README la diferencia con la consigna original para la defensa oral.</a:t>
-            </a:r>
-            <a:endParaRPr lang="en-US" sz="1700" dirty="0"/>
-          </a:p>
-          <a:p>
-            <a:pPr marL="342900" indent="-342900">
-              <a:lnSpc>
-                <a:spcPct val="125000"/>
-              </a:lnSpc>
-              <a:buSzPct val="100000"/>
-              <a:buChar char="•"/>
-            </a:pPr>
-            <a:r>
-              <a:rPr lang="en-US" sz="1700" b="1" dirty="0">
-                <a:solidFill>
-                  <a:srgbClr val="3B2418"/>
-                </a:solidFill>
-                <a:latin typeface="Calibri" pitchFamily="34" charset="0"/>
-                <a:ea typeface="Calibri" pitchFamily="34" charset="-122"/>
-                <a:cs typeface="Calibri" pitchFamily="34" charset="-120"/>
-              </a:rPr>
-              <a:t>Mantener el contrato de la API al agregar "hojas extra".</a:t>
-            </a:r>
-            <a:endParaRPr lang="en-US" sz="1700" dirty="0"/>
-          </a:p>
-          <a:p>
-            <a:pPr lvl="1" indent="0" marL="0">
-              <a:lnSpc>
-                <a:spcPct val="125000"/>
-              </a:lnSpc>
-              <a:buNone/>
-            </a:pPr>
-            <a:r>
-              <a:rPr lang="en-US" sz="1450" dirty="0">
-                <a:solidFill>
-                  <a:srgbClr val="2B2118"/>
-                </a:solidFill>
-                <a:latin typeface="Calibri" pitchFamily="34" charset="0"/>
-                <a:ea typeface="Calibri" pitchFamily="34" charset="-122"/>
-                <a:cs typeface="Calibri" pitchFamily="34" charset="-120"/>
-              </a:rPr>
-              <a:t>Se decidió que cada producto ocupe una sola línea por carrito, para no romper el contrato de DELETE/PUT /api/carts/:cid/products/:pid (identifican la línea solo por :pid).</a:t>
-            </a:r>
-            <a:endParaRPr lang="en-US" sz="1700" dirty="0"/>
-          </a:p>
-        </p:txBody>
-      </p:sp>
-      <p:sp>
-        <p:nvSpPr>
-          <p:cNvPr id="7" name="Text 5"/>
-          <p:cNvSpPr/>
-          <p:nvPr/>
-        </p:nvSpPr>
-        <p:spPr>
-          <a:xfrm>
-            <a:off x="457200" y="6537960"/>
-            <a:ext cx="8229600" cy="274320"/>
+          <a:bodyPr wrap="square" rtlCol="0" anchor="ctr"/>
+          <a:lstStyle/>
+          <a:p>
+            <a:pPr indent="0" marL="0">
+              <a:buNone/>
+            </a:pPr>
+            <a:r>
+              <a:rPr lang="en-US" sz="3400" b="1" dirty="0">
+                <a:solidFill>
+                  <a:srgbClr val="FFFFFF"/>
+                </a:solidFill>
+                <a:latin typeface="Calibri" pitchFamily="34" charset="0"/>
+                <a:ea typeface="Calibri" pitchFamily="34" charset="-122"/>
+                <a:cs typeface="Calibri" pitchFamily="34" charset="-120"/>
+              </a:rPr>
+              <a:t>Cierre del proyecto</a:t>
+            </a:r>
+            <a:endParaRPr lang="en-US" sz="3400" dirty="0"/>
+          </a:p>
+        </p:txBody>
+      </p:sp>
+      <p:sp>
+        <p:nvSpPr>
+          <p:cNvPr id="5" name="Text 3"/>
+          <p:cNvSpPr/>
+          <p:nvPr/>
+        </p:nvSpPr>
+        <p:spPr>
+          <a:xfrm>
+            <a:off x="868680" y="4892040"/>
+            <a:ext cx="10058400" cy="457200"/>
           </a:xfrm>
           <a:prstGeom prst="rect">
             <a:avLst/>
@@ -20267,17 +20341,17 @@
               <a:buNone/>
             </a:pPr>
             <a:r>
-              <a:rPr lang="en-US" sz="900" dirty="0">
-                <a:solidFill>
-                  <a:srgbClr val="7A6A57"/>
-                </a:solidFill>
-                <a:latin typeface="Calibri" pitchFamily="34" charset="0"/>
-                <a:ea typeface="Calibri" pitchFamily="34" charset="-122"/>
-                <a:cs typeface="Calibri" pitchFamily="34" charset="-120"/>
-              </a:rPr>
-              <a:t>CAPTURE TUC — Proyecto final Backend, CoderHouse</a:t>
-            </a:r>
-            <a:endParaRPr lang="en-US" sz="900" dirty="0"/>
+              <a:rPr lang="en-US" sz="1600" i="1" dirty="0">
+                <a:solidFill>
+                  <a:srgbClr val="E9DCC8"/>
+                </a:solidFill>
+                <a:latin typeface="Calibri" pitchFamily="34" charset="0"/>
+                <a:ea typeface="Calibri" pitchFamily="34" charset="-122"/>
+                <a:cs typeface="Calibri" pitchFamily="34" charset="-120"/>
+              </a:rPr>
+              <a:t>Dificultades, soluciones y mejoras futuras</a:t>
+            </a:r>
+            <a:endParaRPr lang="en-US" sz="1600" dirty="0"/>
           </a:p>
         </p:txBody>
       </p:sp>
@@ -20407,7 +20481,7 @@
                 <a:ea typeface="Calibri" pitchFamily="34" charset="-122"/>
                 <a:cs typeface="Calibri" pitchFamily="34" charset="-120"/>
               </a:rPr>
-              <a:t>Mejoras futuras</a:t>
+              <a:t>Dificultades encontradas y soluciones</a:t>
             </a:r>
             <a:endParaRPr lang="en-US" sz="2800" dirty="0"/>
           </a:p>
@@ -20465,7 +20539,27 @@
               <a:buChar char="•"/>
             </a:pPr>
             <a:r>
-              <a:rPr lang="en-US" sz="1700" dirty="0">
+              <a:rPr lang="en-US" sz="1700" b="1" dirty="0">
+                <a:solidFill>
+                  <a:srgbClr val="3B2418"/>
+                </a:solidFill>
+                <a:latin typeface="Calibri" pitchFamily="34" charset="0"/>
+                <a:ea typeface="Calibri" pitchFamily="34" charset="-122"/>
+                <a:cs typeface="Calibri" pitchFamily="34" charset="-120"/>
+              </a:rPr>
+              <a:t>Conexión a MongoDB Atlas fallaba con "querySrv ECONNREFUSED".</a:t>
+            </a:r>
+            <a:endParaRPr lang="en-US" sz="1700" dirty="0"/>
+          </a:p>
+          <a:p>
+            <a:pPr lvl="1" indent="0" marL="0">
+              <a:lnSpc>
+                <a:spcPct val="125000"/>
+              </a:lnSpc>
+              <a:buNone/>
+            </a:pPr>
+            <a:r>
+              <a:rPr lang="en-US" sz="1450" dirty="0">
                 <a:solidFill>
                   <a:srgbClr val="2B2118"/>
                 </a:solidFill>
@@ -20473,7 +20567,7 @@
                 <a:ea typeface="Calibri" pitchFamily="34" charset="-122"/>
                 <a:cs typeface="Calibri" pitchFamily="34" charset="-120"/>
               </a:rPr>
-              <a:t>Autenticación real para el panel de gestión (hoy es una ruta sin link público, pero sin login).</a:t>
+              <a:t>El DNS local de la red (127.0.0.1) no resolvía los registros SRV que usa mongodb+srv://. Se solucionó apuntando la resolución DNS del proceso de Node a un servidor público (8.8.8.8), sin tocar la red del sistema ni la cadena de conexión (src/config/db.js).</a:t>
             </a:r>
             <a:endParaRPr lang="en-US" sz="1700" dirty="0"/>
           </a:p>
@@ -20486,7 +20580,27 @@
               <a:buChar char="•"/>
             </a:pPr>
             <a:r>
-              <a:rPr lang="en-US" sz="1700" dirty="0">
+              <a:rPr lang="en-US" sz="1700" b="1" dirty="0">
+                <a:solidFill>
+                  <a:srgbClr val="3B2418"/>
+                </a:solidFill>
+                <a:latin typeface="Calibri" pitchFamily="34" charset="0"/>
+                <a:ea typeface="Calibri" pitchFamily="34" charset="-122"/>
+                <a:cs typeface="Calibri" pitchFamily="34" charset="-120"/>
+              </a:rPr>
+              <a:t>Simplificar el modelo sin perder de vista la consigna académica.</a:t>
+            </a:r>
+            <a:endParaRPr lang="en-US" sz="1700" dirty="0"/>
+          </a:p>
+          <a:p>
+            <a:pPr lvl="1" indent="0" marL="0">
+              <a:lnSpc>
+                <a:spcPct val="125000"/>
+              </a:lnSpc>
+              <a:buNone/>
+            </a:pPr>
+            <a:r>
+              <a:rPr lang="en-US" sz="1450" dirty="0">
                 <a:solidFill>
                   <a:srgbClr val="2B2118"/>
                 </a:solidFill>
@@ -20494,7 +20608,7 @@
                 <a:ea typeface="Calibri" pitchFamily="34" charset="-122"/>
                 <a:cs typeface="Calibri" pitchFamily="34" charset="-120"/>
               </a:rPr>
-              <a:t>Subida de imágenes en vez de URLs de texto para los thumbnails.</a:t>
+              <a:t>El negocio real no usaba "acabado", "orientación" ni "material". Se sacaron a pedido del negocio; "código" (SKU) se reincorporó después porque la versión final de la consigna volvió a exigirlo — documentado en el README para la defensa oral.</a:t>
             </a:r>
             <a:endParaRPr lang="en-US" sz="1700" dirty="0"/>
           </a:p>
@@ -20507,7 +20621,27 @@
               <a:buChar char="•"/>
             </a:pPr>
             <a:r>
-              <a:rPr lang="en-US" sz="1700" dirty="0">
+              <a:rPr lang="en-US" sz="1700" b="1" dirty="0">
+                <a:solidFill>
+                  <a:srgbClr val="3B2418"/>
+                </a:solidFill>
+                <a:latin typeface="Calibri" pitchFamily="34" charset="0"/>
+                <a:ea typeface="Calibri" pitchFamily="34" charset="-122"/>
+                <a:cs typeface="Calibri" pitchFamily="34" charset="-120"/>
+              </a:rPr>
+              <a:t>Mantener el contrato de la API al agregar "hojas extra".</a:t>
+            </a:r>
+            <a:endParaRPr lang="en-US" sz="1700" dirty="0"/>
+          </a:p>
+          <a:p>
+            <a:pPr lvl="1" indent="0" marL="0">
+              <a:lnSpc>
+                <a:spcPct val="125000"/>
+              </a:lnSpc>
+              <a:buNone/>
+            </a:pPr>
+            <a:r>
+              <a:rPr lang="en-US" sz="1450" dirty="0">
                 <a:solidFill>
                   <a:srgbClr val="2B2118"/>
                 </a:solidFill>
@@ -20515,7 +20649,7 @@
                 <a:ea typeface="Calibri" pitchFamily="34" charset="-122"/>
                 <a:cs typeface="Calibri" pitchFamily="34" charset="-120"/>
               </a:rPr>
-              <a:t>Checkout real: convertir el carrito en un pedido con estado (pendiente, confirmado, entregado).</a:t>
+              <a:t>Se decidió que cada producto ocupe una sola línea por carrito, para no romper el contrato de DELETE/PUT /api/carts/:cid/products/:pid (identifican la línea solo por :pid).</a:t>
             </a:r>
             <a:endParaRPr lang="en-US" sz="1700" dirty="0"/>
           </a:p>
@@ -20528,28 +20662,27 @@
               <a:buChar char="•"/>
             </a:pPr>
             <a:r>
-              <a:rPr lang="en-US" sz="1700" dirty="0">
-                <a:solidFill>
-                  <a:srgbClr val="2B2118"/>
-                </a:solidFill>
-                <a:latin typeface="Calibri" pitchFamily="34" charset="0"/>
-                <a:ea typeface="Calibri" pitchFamily="34" charset="-122"/>
-                <a:cs typeface="Calibri" pitchFamily="34" charset="-120"/>
-              </a:rPr>
-              <a:t>Tests automatizados (unitarios sobre services, end-to-end sobre las rutas).</a:t>
+              <a:rPr lang="en-US" sz="1700" b="1" dirty="0">
+                <a:solidFill>
+                  <a:srgbClr val="3B2418"/>
+                </a:solidFill>
+                <a:latin typeface="Calibri" pitchFamily="34" charset="0"/>
+                <a:ea typeface="Calibri" pitchFamily="34" charset="-122"/>
+                <a:cs typeface="Calibri" pitchFamily="34" charset="-120"/>
+              </a:rPr>
+              <a:t>Carrito guardado en el navegador (localStorage) que dejaba de existir en el servidor.</a:t>
             </a:r>
             <a:endParaRPr lang="en-US" sz="1700" dirty="0"/>
           </a:p>
           <a:p>
-            <a:pPr marL="342900" indent="-342900">
+            <a:pPr lvl="1" indent="0" marL="0">
               <a:lnSpc>
                 <a:spcPct val="125000"/>
               </a:lnSpc>
-              <a:buSzPct val="100000"/>
-              <a:buChar char="•"/>
-            </a:pPr>
-            <a:r>
-              <a:rPr lang="en-US" sz="1700" dirty="0">
+              <a:buNone/>
+            </a:pPr>
+            <a:r>
+              <a:rPr lang="en-US" sz="1450" dirty="0">
                 <a:solidFill>
                   <a:srgbClr val="2B2118"/>
                 </a:solidFill>
@@ -20557,7 +20690,7 @@
                 <a:ea typeface="Calibri" pitchFamily="34" charset="-122"/>
                 <a:cs typeface="Calibri" pitchFamily="34" charset="-120"/>
               </a:rPr>
-              <a:t>Búsqueda por texto libre en título/descripción con índice de texto de MongoDB.</a:t>
+              <a:t>Al limpiar datos de prueba, el ID de carrito cacheado en el navegador quedaba "vivo" en el cliente pero "muerto" en la base — el link "Mi carrito" rompía. Se corrigió validando el ID contra el servidor antes de usarlo, y descartándolo automáticamente si ya no existe.</a:t>
             </a:r>
             <a:endParaRPr lang="en-US" sz="1700" dirty="0"/>
           </a:p>
@@ -20642,6 +20775,327 @@
         </p:nvSpPr>
         <p:spPr>
           <a:xfrm>
+            <a:off x="548640" y="411480"/>
+            <a:ext cx="1563624" cy="329184"/>
+          </a:xfrm>
+          <a:prstGeom prst="roundRect">
+            <a:avLst>
+              <a:gd name="adj" fmla="val 22222"/>
+            </a:avLst>
+          </a:prstGeom>
+          <a:solidFill>
+            <a:srgbClr val="C6A369"/>
+          </a:solidFill>
+          <a:ln/>
+        </p:spPr>
+      </p:sp>
+      <p:sp>
+        <p:nvSpPr>
+          <p:cNvPr id="3" name="Text 1"/>
+          <p:cNvSpPr/>
+          <p:nvPr/>
+        </p:nvSpPr>
+        <p:spPr>
+          <a:xfrm>
+            <a:off x="548640" y="411480"/>
+            <a:ext cx="1563624" cy="329184"/>
+          </a:xfrm>
+          <a:prstGeom prst="rect">
+            <a:avLst/>
+          </a:prstGeom>
+          <a:noFill/>
+          <a:ln/>
+        </p:spPr>
+        <p:txBody>
+          <a:bodyPr wrap="square" rtlCol="0" anchor="ctr"/>
+          <a:lstStyle/>
+          <a:p>
+            <a:pPr algn="ctr" indent="0" marL="0">
+              <a:buNone/>
+            </a:pPr>
+            <a:r>
+              <a:rPr lang="en-US" sz="1200" b="1" dirty="0">
+                <a:solidFill>
+                  <a:srgbClr val="3B2418"/>
+                </a:solidFill>
+                <a:latin typeface="Calibri" pitchFamily="34" charset="0"/>
+                <a:ea typeface="Calibri" pitchFamily="34" charset="-122"/>
+                <a:cs typeface="Calibri" pitchFamily="34" charset="-120"/>
+              </a:rPr>
+              <a:t>10 · Cierre</a:t>
+            </a:r>
+            <a:endParaRPr lang="en-US" sz="1200" dirty="0"/>
+          </a:p>
+        </p:txBody>
+      </p:sp>
+      <p:sp>
+        <p:nvSpPr>
+          <p:cNvPr id="4" name="Text 2"/>
+          <p:cNvSpPr/>
+          <p:nvPr/>
+        </p:nvSpPr>
+        <p:spPr>
+          <a:xfrm>
+            <a:off x="548640" y="822960"/>
+            <a:ext cx="11064240" cy="731520"/>
+          </a:xfrm>
+          <a:prstGeom prst="rect">
+            <a:avLst/>
+          </a:prstGeom>
+          <a:noFill/>
+          <a:ln/>
+        </p:spPr>
+        <p:txBody>
+          <a:bodyPr wrap="square" rtlCol="0" anchor="ctr"/>
+          <a:lstStyle/>
+          <a:p>
+            <a:pPr indent="0" marL="0">
+              <a:buNone/>
+            </a:pPr>
+            <a:r>
+              <a:rPr lang="en-US" sz="2800" b="1" dirty="0">
+                <a:solidFill>
+                  <a:srgbClr val="3B2418"/>
+                </a:solidFill>
+                <a:latin typeface="Calibri" pitchFamily="34" charset="0"/>
+                <a:ea typeface="Calibri" pitchFamily="34" charset="-122"/>
+                <a:cs typeface="Calibri" pitchFamily="34" charset="-120"/>
+              </a:rPr>
+              <a:t>Mejoras futuras</a:t>
+            </a:r>
+            <a:endParaRPr lang="en-US" sz="2800" dirty="0"/>
+          </a:p>
+        </p:txBody>
+      </p:sp>
+      <p:sp>
+        <p:nvSpPr>
+          <p:cNvPr id="5" name="Shape 3"/>
+          <p:cNvSpPr/>
+          <p:nvPr/>
+        </p:nvSpPr>
+        <p:spPr>
+          <a:xfrm>
+            <a:off x="548640" y="1508760"/>
+            <a:ext cx="11064240" cy="0"/>
+          </a:xfrm>
+          <a:prstGeom prst="line">
+            <a:avLst/>
+          </a:prstGeom>
+          <a:noFill/>
+          <a:ln w="19050">
+            <a:solidFill>
+              <a:srgbClr val="D9C7A8"/>
+            </a:solidFill>
+            <a:prstDash val="solid"/>
+          </a:ln>
+        </p:spPr>
+      </p:sp>
+      <p:sp>
+        <p:nvSpPr>
+          <p:cNvPr id="6" name="Text 4"/>
+          <p:cNvSpPr/>
+          <p:nvPr/>
+        </p:nvSpPr>
+        <p:spPr>
+          <a:xfrm>
+            <a:off x="640080" y="1783080"/>
+            <a:ext cx="10881360" cy="4206240"/>
+          </a:xfrm>
+          <a:prstGeom prst="rect">
+            <a:avLst/>
+          </a:prstGeom>
+          <a:noFill/>
+          <a:ln/>
+        </p:spPr>
+        <p:txBody>
+          <a:bodyPr wrap="square" rtlCol="0" anchor="t"/>
+          <a:lstStyle/>
+          <a:p>
+            <a:pPr marL="342900" indent="-342900">
+              <a:lnSpc>
+                <a:spcPct val="125000"/>
+              </a:lnSpc>
+              <a:buSzPct val="100000"/>
+              <a:buChar char="•"/>
+            </a:pPr>
+            <a:r>
+              <a:rPr lang="en-US" sz="1700" dirty="0">
+                <a:solidFill>
+                  <a:srgbClr val="2B2118"/>
+                </a:solidFill>
+                <a:latin typeface="Calibri" pitchFamily="34" charset="0"/>
+                <a:ea typeface="Calibri" pitchFamily="34" charset="-122"/>
+                <a:cs typeface="Calibri" pitchFamily="34" charset="-120"/>
+              </a:rPr>
+              <a:t>Autenticación real para el panel de gestión (hoy es una ruta sin link público, pero sin login).</a:t>
+            </a:r>
+            <a:endParaRPr lang="en-US" sz="1700" dirty="0"/>
+          </a:p>
+          <a:p>
+            <a:pPr marL="342900" indent="-342900">
+              <a:lnSpc>
+                <a:spcPct val="125000"/>
+              </a:lnSpc>
+              <a:buSzPct val="100000"/>
+              <a:buChar char="•"/>
+            </a:pPr>
+            <a:r>
+              <a:rPr lang="en-US" sz="1700" dirty="0">
+                <a:solidFill>
+                  <a:srgbClr val="2B2118"/>
+                </a:solidFill>
+                <a:latin typeface="Calibri" pitchFamily="34" charset="0"/>
+                <a:ea typeface="Calibri" pitchFamily="34" charset="-122"/>
+                <a:cs typeface="Calibri" pitchFamily="34" charset="-120"/>
+              </a:rPr>
+              <a:t>Subida de imágenes en vez de URLs de texto para los thumbnails.</a:t>
+            </a:r>
+            <a:endParaRPr lang="en-US" sz="1700" dirty="0"/>
+          </a:p>
+          <a:p>
+            <a:pPr marL="342900" indent="-342900">
+              <a:lnSpc>
+                <a:spcPct val="125000"/>
+              </a:lnSpc>
+              <a:buSzPct val="100000"/>
+              <a:buChar char="•"/>
+            </a:pPr>
+            <a:r>
+              <a:rPr lang="en-US" sz="1700" dirty="0">
+                <a:solidFill>
+                  <a:srgbClr val="2B2118"/>
+                </a:solidFill>
+                <a:latin typeface="Calibri" pitchFamily="34" charset="0"/>
+                <a:ea typeface="Calibri" pitchFamily="34" charset="-122"/>
+                <a:cs typeface="Calibri" pitchFamily="34" charset="-120"/>
+              </a:rPr>
+              <a:t>Checkout real: convertir el carrito en un pedido con estado (pendiente, confirmado, entregado).</a:t>
+            </a:r>
+            <a:endParaRPr lang="en-US" sz="1700" dirty="0"/>
+          </a:p>
+          <a:p>
+            <a:pPr marL="342900" indent="-342900">
+              <a:lnSpc>
+                <a:spcPct val="125000"/>
+              </a:lnSpc>
+              <a:buSzPct val="100000"/>
+              <a:buChar char="•"/>
+            </a:pPr>
+            <a:r>
+              <a:rPr lang="en-US" sz="1700" dirty="0">
+                <a:solidFill>
+                  <a:srgbClr val="2B2118"/>
+                </a:solidFill>
+                <a:latin typeface="Calibri" pitchFamily="34" charset="0"/>
+                <a:ea typeface="Calibri" pitchFamily="34" charset="-122"/>
+                <a:cs typeface="Calibri" pitchFamily="34" charset="-120"/>
+              </a:rPr>
+              <a:t>Tests automatizados (unitarios sobre services, end-to-end sobre las rutas).</a:t>
+            </a:r>
+            <a:endParaRPr lang="en-US" sz="1700" dirty="0"/>
+          </a:p>
+          <a:p>
+            <a:pPr marL="342900" indent="-342900">
+              <a:lnSpc>
+                <a:spcPct val="125000"/>
+              </a:lnSpc>
+              <a:buSzPct val="100000"/>
+              <a:buChar char="•"/>
+            </a:pPr>
+            <a:r>
+              <a:rPr lang="en-US" sz="1700" dirty="0">
+                <a:solidFill>
+                  <a:srgbClr val="2B2118"/>
+                </a:solidFill>
+                <a:latin typeface="Calibri" pitchFamily="34" charset="0"/>
+                <a:ea typeface="Calibri" pitchFamily="34" charset="-122"/>
+                <a:cs typeface="Calibri" pitchFamily="34" charset="-120"/>
+              </a:rPr>
+              <a:t>Búsqueda por texto libre en título/descripción con índice de texto de MongoDB.</a:t>
+            </a:r>
+            <a:endParaRPr lang="en-US" sz="1700" dirty="0"/>
+          </a:p>
+        </p:txBody>
+      </p:sp>
+      <p:sp>
+        <p:nvSpPr>
+          <p:cNvPr id="7" name="Text 5"/>
+          <p:cNvSpPr/>
+          <p:nvPr/>
+        </p:nvSpPr>
+        <p:spPr>
+          <a:xfrm>
+            <a:off x="457200" y="6537960"/>
+            <a:ext cx="8229600" cy="274320"/>
+          </a:xfrm>
+          <a:prstGeom prst="rect">
+            <a:avLst/>
+          </a:prstGeom>
+          <a:noFill/>
+          <a:ln/>
+        </p:spPr>
+        <p:txBody>
+          <a:bodyPr wrap="square" rtlCol="0" anchor="ctr"/>
+          <a:lstStyle/>
+          <a:p>
+            <a:pPr indent="0" marL="0">
+              <a:buNone/>
+            </a:pPr>
+            <a:r>
+              <a:rPr lang="en-US" sz="900" dirty="0">
+                <a:solidFill>
+                  <a:srgbClr val="7A6A57"/>
+                </a:solidFill>
+                <a:latin typeface="Calibri" pitchFamily="34" charset="0"/>
+                <a:ea typeface="Calibri" pitchFamily="34" charset="-122"/>
+                <a:cs typeface="Calibri" pitchFamily="34" charset="-120"/>
+              </a:rPr>
+              <a:t>CAPTURE TUC — Proyecto final Backend, CoderHouse</a:t>
+            </a:r>
+            <a:endParaRPr lang="en-US" sz="900" dirty="0"/>
+          </a:p>
+        </p:txBody>
+      </p:sp>
+    </p:spTree>
+  </p:cSld>
+  <p:clrMapOvr>
+    <a:masterClrMapping/>
+  </p:clrMapOvr>
+</p:sld>
+</file>
+
+<file path=ppt/slides/slide43.xml><?xml version="1.0" encoding="utf-8"?>
+<p:sld xmlns:a="http://schemas.openxmlformats.org/drawingml/2006/main" xmlns:r="http://schemas.openxmlformats.org/officeDocument/2006/relationships" xmlns:p="http://schemas.openxmlformats.org/presentationml/2006/main">
+  <p:cSld name="Slide 43">
+    <p:bg>
+      <p:bgPr>
+        <a:solidFill>
+          <a:srgbClr val="F2E9DC"/>
+        </a:solidFill>
+      </p:bgPr>
+    </p:bg>
+    <p:spTree>
+      <p:nvGrpSpPr>
+        <p:cNvPr id="1" name=""/>
+        <p:cNvGrpSpPr/>
+        <p:nvPr/>
+      </p:nvGrpSpPr>
+      <p:grpSpPr>
+        <a:xfrm>
+          <a:off x="0" y="0"/>
+          <a:ext cx="0" cy="0"/>
+          <a:chOff x="0" y="0"/>
+          <a:chExt cx="0" cy="0"/>
+        </a:xfrm>
+      </p:grpSpPr>
+      <p:sp>
+        <p:nvSpPr>
+          <p:cNvPr id="2" name="Shape 0"/>
+          <p:cNvSpPr/>
+          <p:nvPr/>
+        </p:nvSpPr>
+        <p:spPr>
+          <a:xfrm>
             <a:off x="0" y="0"/>
             <a:ext cx="12188952" cy="6858000"/>
           </a:xfrm>
@@ -21307,6 +21761,26 @@
                 <a:cs typeface="Calibri" pitchFamily="34" charset="-120"/>
               </a:rPr>
               <a:t>Persistencia intercambiable: MongoDB Atlas o FileSystem, sin cambiar una línea de código (solo una variable de entorno).</a:t>
+            </a:r>
+            <a:endParaRPr lang="en-US" sz="1700" dirty="0"/>
+          </a:p>
+          <a:p>
+            <a:pPr lvl="1" indent="0" marL="0">
+              <a:lnSpc>
+                <a:spcPct val="125000"/>
+              </a:lnSpc>
+              <a:buNone/>
+            </a:pPr>
+            <a:r>
+              <a:rPr lang="en-US" sz="1450" dirty="0">
+                <a:solidFill>
+                  <a:srgbClr val="2B2118"/>
+                </a:solidFill>
+                <a:latin typeface="Calibri" pitchFamily="34" charset="0"/>
+                <a:ea typeface="Calibri" pitchFamily="34" charset="-122"/>
+                <a:cs typeface="Calibri" pitchFamily="34" charset="-120"/>
+              </a:rPr>
+              <a:t>Extra (fuera de la consigna técnica): opción de pago Transferencia/Efectivo en el carrito, con los datos bancarios reales del negocio.</a:t>
             </a:r>
             <a:endParaRPr lang="en-US" sz="1700" dirty="0"/>
           </a:p>

</xml_diff>